<commit_message>
Upgrade face matching to verified YuNet and SFace models
</commit_message>
<xml_diff>
--- a/docs/thuyet-trinh-opencv.pptx
+++ b/docs/thuyet-trinh-opencv.pptx
@@ -648,7 +648,7 @@
           <a:lstStyle/>
           <a:p>
             <a:r>
-              <a:t>1:40–2:25. Haar phát hiện vị trí mặt, LBPH so khớp trong roster, HSV chỉ đo màu vùng áo. Service attendance là nơi ghi kết quả. Mẫu lưu private trong DB; frame phân tích không lưu. QR mặc định tắt, dữ liệu và migrations cũ giữ lại.</a:t>
+              <a:t>1:40–2:25. YuNet phát hiện5landmark, SFace so cosine trong roster, HSV chỉ đo màu vùng áo. Service attendance là nơi ghi kết quả. Mẫu crop112x112 và embedding128float lưu private trong DB; frame phân tích không lưu. Mẫu LBPH cũ cần enrollment lại3–10ảnh. Cosine≥0.45 và margin≥0.10 chỉ là ngưỡng demo, không phải xác suất. Models chuẩn bị trước, request không tải network. QR mặc định tắt, dữ liệu và migrations cũ giữ lại.</a:t>
             </a:r>
           </a:p>
         </p:txBody>
@@ -858,7 +858,7 @@
           <a:lstStyle/>
           <a:p>
             <a:r>
-              <a:t>4:40–5:35. Mở evidence mới của backend thay vì đọc số test trên slide. Không lấy126test QR lịch sử làm kết quả vision. Giải thích phần nào dùng fixture/mocked detection và phần nào chạy LBPH/HSV thật. Checklist thiết bị thật chưa hoàn tất nếu chưa có log và reviewer.</a:t>
+              <a:t>4:40–5:35. Mở evidence mới của backend thay vì đọc số test trên slide. Không lấy126test QR lịch sử làm kết quả vision. Giải thích phần nào dùng fixture/mocked detection và phần nào chạy SFace/HSV thật. Checklist thiết bị thật chưa hoàn tất nếu chưa có log và reviewer.</a:t>
             </a:r>
           </a:p>
         </p:txBody>
@@ -4015,7 +4015,7 @@
               </a:defRPr>
             </a:pPr>
             <a:r>
-              <a:t>MVP v1.3 • Django UI local • Demo 5–7 phút</a:t>
+              <a:t>MVP v1.4 • Django UI local • Demo 5–7 phút</a:t>
             </a:r>
           </a:p>
         </p:txBody>
@@ -4328,7 +4328,7 @@
               </a:defRPr>
             </a:pPr>
             <a:r>
-              <a:t>OpenCV MVP v1.3 | UI local | Nhân sự xác nhận bắt buộc</a:t>
+              <a:t>OpenCV MVP v1.4 | UI local | Nhân sự xác nhận bắt buộc</a:t>
             </a:r>
           </a:p>
         </p:txBody>
@@ -4784,7 +4784,7 @@
               </a:defRPr>
             </a:pPr>
             <a:r>
-              <a:t>OpenCV MVP v1.3 | UI local | Nhân sự xác nhận bắt buộc</a:t>
+              <a:t>OpenCV MVP v1.4 | UI local | Nhân sự xác nhận bắt buộc</a:t>
             </a:r>
           </a:p>
         </p:txBody>
@@ -5201,7 +5201,7 @@
               </a:defRPr>
             </a:pPr>
             <a:r>
-              <a:t>Haar phát hiện mặt</a:t>
+              <a:t>YuNet: phát hiện 5 landmark</a:t>
             </a:r>
           </a:p>
           <a:p>
@@ -5217,7 +5217,7 @@
               </a:defRPr>
             </a:pPr>
             <a:r>
-              <a:t>LBPH gợi ý danh tính</a:t>
+              <a:t>SFace: embedding + cosine</a:t>
             </a:r>
           </a:p>
           <a:p>
@@ -5523,7 +5523,7 @@
               </a:defRPr>
             </a:pPr>
             <a:r>
-              <a:t>Crop mẫu 128×128 private</a:t>
+              <a:t>Crop112×112 + embedding private</a:t>
             </a:r>
           </a:p>
           <a:p>
@@ -5578,7 +5578,7 @@
               </a:defRPr>
             </a:pPr>
             <a:r>
-              <a:t>OpenCV MVP v1.3 | UI local | Nhân sự xác nhận bắt buộc</a:t>
+              <a:t>OpenCV MVP v1.4 | UI local | Nhân sự xác nhận bắt buộc</a:t>
             </a:r>
           </a:p>
         </p:txBody>
@@ -6066,7 +6066,7 @@
               </a:defRPr>
             </a:pPr>
             <a:r>
-              <a:t>OpenCV MVP v1.3 | UI local | Nhân sự xác nhận bắt buộc</a:t>
+              <a:t>OpenCV MVP v1.4 | UI local | Nhân sự xác nhận bắt buộc</a:t>
             </a:r>
           </a:p>
         </p:txBody>
@@ -6554,7 +6554,7 @@
               </a:defRPr>
             </a:pPr>
             <a:r>
-              <a:t>OpenCV MVP v1.3 | UI local | Nhân sự xác nhận bắt buộc</a:t>
+              <a:t>OpenCV MVP v1.4 | UI local | Nhân sự xác nhận bắt buộc</a:t>
             </a:r>
           </a:p>
         </p:txBody>
@@ -7042,7 +7042,7 @@
               </a:defRPr>
             </a:pPr>
             <a:r>
-              <a:t>OpenCV MVP v1.3 | UI local | Nhân sự xác nhận bắt buộc</a:t>
+              <a:t>OpenCV MVP v1.4 | UI local | Nhân sự xác nhận bắt buộc</a:t>
             </a:r>
           </a:p>
         </p:txBody>
@@ -7530,7 +7530,7 @@
               </a:defRPr>
             </a:pPr>
             <a:r>
-              <a:t>OpenCV MVP v1.3 | UI local | Nhân sự xác nhận bắt buộc</a:t>
+              <a:t>OpenCV MVP v1.4 | UI local | Nhân sự xác nhận bắt buộc</a:t>
             </a:r>
           </a:p>
         </p:txBody>

</xml_diff>

<commit_message>
feat: implement v1.5 automatic attendance uniform workflow and scoped CRUD
</commit_message>
<xml_diff>
--- a/docs/thuyet-trinh-opencv.pptx
+++ b/docs/thuyet-trinh-opencv.pptx
@@ -508,7 +508,7 @@
           <a:lstStyle/>
           <a:p>
             <a:r>
-              <a:t>0:00–0:50. Giới thiệu bài toán và vai trò. Nói rõ UI local được người dùng cho phép trước gate ngày18/10/2026; browser/camera cần evidence riêng. Không công bố độ chính xác hoặc chống giả khi chưa có đánh giá thực tế.</a:t>
+              <a:t>0:00–0:45. Nêu thay đổi v1.5 được người dùng yêu cầu: bỏ xác nhận từng học sinh. Phê duyệt PM API và validation kỹ thuật là hai việc riêng.</a:t>
             </a:r>
           </a:p>
         </p:txBody>
@@ -578,7 +578,7 @@
           <a:lstStyle/>
           <a:p>
             <a:r>
-              <a:t>0:50–1:40. Trình bày đường đi dữ liệu. Enrollment và ảnh đánh giá phải tách biệt. UNKNOWN, nhiều mặt hoặc ảnh mờ chuyển chụp lại/manual. PRESENT chỉ được ghi sau xác nhận hợp lệ; không tự suy đồng phục đạt.</a:t>
+              <a:t>0:45–1:35. Ngưỡng auto khởi đầu cosine0.60/margin0.15 cần calibration. Hai frame kiểm tra nhất quán, không liveness. Không tuyên bố accuracy toàn trường từ ảnh demo.</a:t>
             </a:r>
           </a:p>
         </p:txBody>
@@ -648,7 +648,7 @@
           <a:lstStyle/>
           <a:p>
             <a:r>
-              <a:t>1:40–2:25. YuNet phát hiện5landmark, SFace so cosine trong roster, HSV chỉ đo màu vùng áo. Service attendance là nơi ghi kết quả. Mẫu crop112x112 và embedding128float lưu private trong DB; frame phân tích không lưu. Mẫu LBPH cũ cần enrollment lại3–10ảnh. Cosine≥0.45 và margin≥0.10 chỉ là ngưỡng demo, không phải xác suất. Models chuẩn bị trước, request không tải network. QR mặc định tắt, dữ liệu và migrations cũ giữ lại.</a:t>
+              <a:t>1:35–2:25. Hiện chưa có bộ ảnh đồng phục trường nên chưa huấn luyện/nghiệm thu model. Có thể demo UI/no-model và cách chuẩn bị ảnh, không giả vờ nhận diện đúng logo.</a:t>
             </a:r>
           </a:p>
         </p:txBody>
@@ -718,7 +718,7 @@
           <a:lstStyle/>
           <a:p>
             <a:r>
-              <a:t>2:25–3:50. Mở http://127.0.0.1:8000/; API client api-requests.http là dự phòng. UI dùng API cũ và quyền cũ. Mẫu multipart images lặp 3–10 file; scan chỉ một image, không student_id. Nhìn người thực tế trước confirm. arrived_at lấy scanned_at server. Chỉ chọn COMPLIANT sau kiểm tra thực tế; có thể bỏ uniform để kiểm tra sau.</a:t>
+              <a:t>2:25–3:10. Tạo và sửa một hồ sơ fictitious. Chỉ rõ thay đổi hồ sơ không viết lại snapshot buổi trước; version chống hai người ghi đè.</a:t>
             </a:r>
           </a:p>
         </p:txBody>
@@ -788,7 +788,7 @@
           <a:lstStyle/>
           <a:p>
             <a:r>
-              <a:t>3:50–4:40. Cho thấy một trường hợp không nhận diện hoặc dùng dữ liệu thử có nhãn. Không sửa student_id để chọn người trong confirm. Mẫu mới/xóa mẫu, manual, transfer và close làm proposal cũ không còn dùng để ghi attendance.</a:t>
+              <a:t>3:10–4:25. Dùng dữ liệu thử được phép, không public ảnh học sinh. Camera thật cần thiết bị và quyền. Ảnh upload hai tấm kiểm tra pipeline; không phải chứng minh live camera.</a:t>
             </a:r>
           </a:p>
         </p:txBody>
@@ -858,7 +858,7 @@
           <a:lstStyle/>
           <a:p>
             <a:r>
-              <a:t>4:40–5:35. Mở evidence mới của backend thay vì đọc số test trên slide. Không lấy126test QR lịch sử làm kết quả vision. Giải thích phần nào dùng fixture/mocked detection và phần nào chạy SFace/HSV thật. Checklist thiết bị thật chưa hoàn tất nếu chưa có log và reviewer.</a:t>
+              <a:t>4:25–5:15. Mở docs/project-management/evidence/v1.5 thay vì đọc số test cố định trên slide. Workflow mock không chứng minh model accuracy; phân biệt rõ ảnh mặt thật và camera giả lập.</a:t>
             </a:r>
           </a:p>
         </p:txBody>
@@ -928,7 +928,7 @@
           <a:lstStyle/>
           <a:p>
             <a:r>
-              <a:t>5:35–6:30, dành phần còn lại cho câu hỏi. Cần đánh giá trên bộ ảnh được phép, tách enrollment/evaluation trước mọi tuyên bố accuracy. Rate limit không phải rolling window hoặc giới hạn toàn hệ thống nhiều process. UI local đã được cho phép trước gate bằng yêu cầu làm luôn UI để demo. Ngoại lệ không phê duyệt API hoặc deploy.</a:t>
+              <a:t>5:15–6:20. Kết luận bằng việc mở backlog và chỉ task nào đã kiểm chứng, task nào thiếu dữ liệu. Không tick toàn bộ task vì có file hoặc vì demo nhỏ chạy được.</a:t>
             </a:r>
           </a:p>
         </p:txBody>
@@ -3976,7 +3976,7 @@
               </a:defRPr>
             </a:pPr>
             <a:r>
-              <a:t>Điểm danh với OpenCV</a:t>
+              <a:t>Điểm danh tự động với OpenCV</a:t>
             </a:r>
           </a:p>
         </p:txBody>
@@ -4015,7 +4015,7 @@
               </a:defRPr>
             </a:pPr>
             <a:r>
-              <a:t>MVP v1.4 • Django UI local • Demo 5–7 phút</a:t>
+              <a:t>MVP v1.5 • Django • Demo 5–7 phút</a:t>
             </a:r>
           </a:p>
         </p:txBody>
@@ -4136,7 +4136,7 @@
               </a:defRPr>
             </a:pPr>
             <a:r>
-              <a:t>• Ghi nhận có mặt, giờ đến và đồng phục theo từng buổi học.</a:t>
+              <a:t>• Nhận diện mặt, ghi có mặt và giờ đến theo buổi.</a:t>
             </a:r>
           </a:p>
           <a:p>
@@ -4152,7 +4152,7 @@
               </a:defRPr>
             </a:pPr>
             <a:r>
-              <a:t>• GVCN xem lớp được giao; giám thị quản lý toàn bộ.</a:t>
+              <a:t>• Giáo viên chỉ xử lý ngoại lệ đồng phục và ghi lý do.</a:t>
             </a:r>
           </a:p>
         </p:txBody>
@@ -4234,7 +4234,7 @@
               </a:defRPr>
             </a:pPr>
             <a:r>
-              <a:t>Nguyên tắc</a:t>
+              <a:t>Phạm vi</a:t>
             </a:r>
           </a:p>
         </p:txBody>
@@ -4273,7 +4273,7 @@
               </a:defRPr>
             </a:pPr>
             <a:r>
-              <a:t>• OpenCV chỉ gợi ý; nhân sự kiểm tra người thực tế rồi xác nhận.</a:t>
+              <a:t>• Quản lý lớp và học sinh, sức chứa và sĩ số thực tế.</a:t>
             </a:r>
           </a:p>
           <a:p>
@@ -4289,7 +4289,7 @@
               </a:defRPr>
             </a:pPr>
             <a:r>
-              <a:t>• Không chắc chắn hoặc camera lỗi: điểm danh thủ công.</a:t>
+              <a:t>• GVCN theo lớp được giao; giám thị quản lý toàn phạm vi.</a:t>
             </a:r>
           </a:p>
         </p:txBody>
@@ -4328,7 +4328,7 @@
               </a:defRPr>
             </a:pPr>
             <a:r>
-              <a:t>OpenCV MVP v1.4 | UI local | Nhân sự xác nhận bắt buộc</a:t>
+              <a:t>OpenCV MVP v1.5 | Tự điểm danh | Giáo viên xử lý ngoại lệ</a:t>
             </a:r>
           </a:p>
         </p:txBody>
@@ -4432,7 +4432,7 @@
               </a:defRPr>
             </a:pPr>
             <a:r>
-              <a:t>Một ảnh → một đề xuất → xác nhận</a:t>
+              <a:t>Hai ảnh → nhận diện → tự điểm danh</a:t>
             </a:r>
           </a:p>
         </p:txBody>
@@ -4471,7 +4471,7 @@
               </a:defRPr>
             </a:pPr>
             <a:r>
-              <a:t>Scan không tự ghi PRESENT</a:t>
+              <a:t>Server quyết định danh tính, không cần nút confirm</a:t>
             </a:r>
           </a:p>
         </p:txBody>
@@ -4553,7 +4553,7 @@
               </a:defRPr>
             </a:pPr>
             <a:r>
-              <a:t>1. Chuẩn bị</a:t>
+              <a:t>Chuẩn bị</a:t>
             </a:r>
           </a:p>
         </p:txBody>
@@ -4592,7 +4592,7 @@
               </a:defRPr>
             </a:pPr>
             <a:r>
-              <a:t>• Nhân sự đăng nhập và mở buổi đúng quyền, ngày và khung giờ.</a:t>
+              <a:t>• Mở buổi đúng ngày/khung giờ và đăng ký 3–10 ảnh mỗi người.</a:t>
             </a:r>
           </a:p>
           <a:p>
@@ -4608,7 +4608,7 @@
               </a:defRPr>
             </a:pPr>
             <a:r>
-              <a:t>• Đăng ký riêng 3–10 mẫu của mỗi người; ảnh hồ sơ không tự thành mẫu.</a:t>
+              <a:t>• Hai ảnh khác nhau phải cùng một mặt rõ trong roster.</a:t>
             </a:r>
           </a:p>
         </p:txBody>
@@ -4690,7 +4690,7 @@
               </a:defRPr>
             </a:pPr>
             <a:r>
-              <a:t>2. Gợi ý và quyết định</a:t>
+              <a:t>Tự ghi nhận</a:t>
             </a:r>
           </a:p>
         </p:txBody>
@@ -4729,7 +4729,7 @@
               </a:defRPr>
             </a:pPr>
             <a:r>
-              <a:t>• Gửi một ảnh: ứng viên + màu áo; proposal PENDING tối đa 120 giây.</a:t>
+              <a:t>• YuNet phát hiện/căn chỉnh; SFace so cosine với roster.</a:t>
             </a:r>
           </a:p>
           <a:p>
@@ -4745,7 +4745,7 @@
               </a:defRPr>
             </a:pPr>
             <a:r>
-              <a:t>• Nhìn người thật → xác nhận danh tính → attendance source VISION.</a:t>
+              <a:t>• Đủ điều kiện: PRESENT + giờ đến server; không chắc: chụp lại/manual.</a:t>
             </a:r>
           </a:p>
         </p:txBody>
@@ -4784,7 +4784,7 @@
               </a:defRPr>
             </a:pPr>
             <a:r>
-              <a:t>OpenCV MVP v1.4 | UI local | Nhân sự xác nhận bắt buộc</a:t>
+              <a:t>OpenCV MVP v1.5 | Tự điểm danh | Giáo viên xử lý ngoại lệ</a:t>
             </a:r>
           </a:p>
         </p:txBody>
@@ -4888,7 +4888,7 @@
               </a:defRPr>
             </a:pPr>
             <a:r>
-              <a:t>Kiến trúc cục bộ, dữ liệu private</a:t>
+              <a:t>Đồng phục đúng mẫu trường</a:t>
             </a:r>
           </a:p>
         </p:txBody>
@@ -4927,7 +4927,7 @@
               </a:defRPr>
             </a:pPr>
             <a:r>
-              <a:t>Django session + CSRF + kiểm tra phạm vi lớp ở từng API</a:t>
+              <a:t>Không dùng màu áo làm bằng chứng logo/mẫu</a:t>
             </a:r>
           </a:p>
         </p:txBody>
@@ -4940,8 +4940,8 @@
         </p:nvSpPr>
         <p:spPr>
           <a:xfrm>
-            <a:off x="594360" y="2011680"/>
-            <a:ext cx="2697480" cy="3383280"/>
+            <a:off x="594360" y="1938528"/>
+            <a:ext cx="5477256" cy="3995928"/>
           </a:xfrm>
           <a:prstGeom prst="roundRect">
             <a:avLst/>
@@ -4983,8 +4983,8 @@
         </p:nvSpPr>
         <p:spPr>
           <a:xfrm>
-            <a:off x="758952" y="2212848"/>
-            <a:ext cx="2377440" cy="502920"/>
+            <a:off x="822960" y="2148840"/>
+            <a:ext cx="4983480" cy="502920"/>
           </a:xfrm>
           <a:prstGeom prst="rect">
             <a:avLst/>
@@ -5001,7 +5001,7 @@
               <a:spcAft>
                 <a:spcPts val="1400"/>
               </a:spcAft>
-              <a:defRPr sz="2200" b="1">
+              <a:defRPr sz="2400" b="1">
                 <a:solidFill>
                   <a:srgbClr val="55D5C6"/>
                 </a:solidFill>
@@ -5009,7 +5009,7 @@
               </a:defRPr>
             </a:pPr>
             <a:r>
-              <a:t>Django UI local</a:t>
+              <a:t>Dữ liệu và model</a:t>
             </a:r>
           </a:p>
         </p:txBody>
@@ -5022,8 +5022,8 @@
         </p:nvSpPr>
         <p:spPr>
           <a:xfrm>
-            <a:off x="758952" y="2852928"/>
-            <a:ext cx="2377440" cy="2377440"/>
+            <a:off x="822960" y="2852928"/>
+            <a:ext cx="4965192" cy="2816352"/>
           </a:xfrm>
           <a:prstGeom prst="rect">
             <a:avLst/>
@@ -5040,7 +5040,7 @@
               <a:spcAft>
                 <a:spcPts val="1400"/>
               </a:spcAft>
-              <a:defRPr sz="2000" b="0">
+              <a:defRPr sz="2100" b="0">
                 <a:solidFill>
                   <a:srgbClr val="F5F8FC"/>
                 </a:solidFill>
@@ -5048,7 +5048,7 @@
               </a:defRPr>
             </a:pPr>
             <a:r>
-              <a:t>Cookie/session của staff</a:t>
+              <a:t>• Bộ ảnh áo riêng, tách train/val/test theo người/buổi.</a:t>
             </a:r>
           </a:p>
           <a:p>
@@ -5056,7 +5056,7 @@
               <a:spcAft>
                 <a:spcPts val="1400"/>
               </a:spcAft>
-              <a:defRPr sz="2000" b="0">
+              <a:defRPr sz="2100" b="0">
                 <a:solidFill>
                   <a:srgbClr val="F5F8FC"/>
                 </a:solidFill>
@@ -5064,23 +5064,7 @@
               </a:defRPr>
             </a:pPr>
             <a:r>
-              <a:t>Camera hoặc upload ảnh</a:t>
-            </a:r>
-          </a:p>
-          <a:p>
-            <a:pPr>
-              <a:spcAft>
-                <a:spcPts val="1400"/>
-              </a:spcAft>
-              <a:defRPr sz="2000" b="0">
-                <a:solidFill>
-                  <a:srgbClr val="F5F8FC"/>
-                </a:solidFill>
-                <a:latin typeface="Arial"/>
-              </a:defRPr>
-            </a:pPr>
-            <a:r>
-              <a:t>Ngoại lệ trước API gate</a:t>
+              <a:t>• Train offline → đánh giá → ONNX hash/version; runtime OpenCV.</a:t>
             </a:r>
           </a:p>
         </p:txBody>
@@ -5093,8 +5077,8 @@
         </p:nvSpPr>
         <p:spPr>
           <a:xfrm>
-            <a:off x="3447288" y="2011680"/>
-            <a:ext cx="2697480" cy="3383280"/>
+            <a:off x="6236208" y="1938528"/>
+            <a:ext cx="5477256" cy="3995928"/>
           </a:xfrm>
           <a:prstGeom prst="roundRect">
             <a:avLst/>
@@ -5136,8 +5120,8 @@
         </p:nvSpPr>
         <p:spPr>
           <a:xfrm>
-            <a:off x="3611880" y="2212848"/>
-            <a:ext cx="2377440" cy="502920"/>
+            <a:off x="6464808" y="2148840"/>
+            <a:ext cx="4983480" cy="502920"/>
           </a:xfrm>
           <a:prstGeom prst="rect">
             <a:avLst/>
@@ -5154,7 +5138,7 @@
               <a:spcAft>
                 <a:spcPts val="1400"/>
               </a:spcAft>
-              <a:defRPr sz="2200" b="1">
+              <a:defRPr sz="2400" b="1">
                 <a:solidFill>
                   <a:srgbClr val="55D5C6"/>
                 </a:solidFill>
@@ -5162,7 +5146,7 @@
               </a:defRPr>
             </a:pPr>
             <a:r>
-              <a:t>Vision</a:t>
+              <a:t>Ba kết quả</a:t>
             </a:r>
           </a:p>
         </p:txBody>
@@ -5175,8 +5159,8 @@
         </p:nvSpPr>
         <p:spPr>
           <a:xfrm>
-            <a:off x="3611880" y="2852928"/>
-            <a:ext cx="2377440" cy="2377440"/>
+            <a:off x="6464808" y="2852928"/>
+            <a:ext cx="4965192" cy="2816352"/>
           </a:xfrm>
           <a:prstGeom prst="rect">
             <a:avLst/>
@@ -5193,7 +5177,7 @@
               <a:spcAft>
                 <a:spcPts val="1400"/>
               </a:spcAft>
-              <a:defRPr sz="2000" b="0">
+              <a:defRPr sz="2100" b="0">
                 <a:solidFill>
                   <a:srgbClr val="F5F8FC"/>
                 </a:solidFill>
@@ -5201,7 +5185,7 @@
               </a:defRPr>
             </a:pPr>
             <a:r>
-              <a:t>YuNet: phát hiện 5 landmark</a:t>
+              <a:t>• Đúng mẫu rõ: tự ghi Đạt; nghi sai: giáo viên ghi lý do.</a:t>
             </a:r>
           </a:p>
           <a:p>
@@ -5209,7 +5193,7 @@
               <a:spcAft>
                 <a:spcPts val="1400"/>
               </a:spcAft>
-              <a:defRPr sz="2000" b="0">
+              <a:defRPr sz="2100" b="0">
                 <a:solidFill>
                   <a:srgbClr val="F5F8FC"/>
                 </a:solidFill>
@@ -5217,336 +5201,14 @@
               </a:defRPr>
             </a:pPr>
             <a:r>
-              <a:t>SFace: embedding + cosine</a:t>
-            </a:r>
-          </a:p>
-          <a:p>
-            <a:pPr>
-              <a:spcAft>
-                <a:spcPts val="1400"/>
-              </a:spcAft>
-              <a:defRPr sz="2000" b="0">
-                <a:solidFill>
-                  <a:srgbClr val="F5F8FC"/>
-                </a:solidFill>
-                <a:latin typeface="Arial"/>
-              </a:defRPr>
-            </a:pPr>
-            <a:r>
-              <a:t>HSV gợi ý màu áo</a:t>
-            </a:r>
-          </a:p>
-        </p:txBody>
-      </p:sp>
-      <p:sp>
-        <p:nvSpPr>
-          <p:cNvPr id="10" name="Rounded Rectangle 9"/>
-          <p:cNvSpPr/>
-          <p:nvPr/>
-        </p:nvSpPr>
-        <p:spPr>
-          <a:xfrm>
-            <a:off x="6300216" y="2011680"/>
-            <a:ext cx="2697480" cy="3383280"/>
-          </a:xfrm>
-          <a:prstGeom prst="roundRect">
-            <a:avLst/>
-          </a:prstGeom>
-          <a:solidFill>
-            <a:srgbClr val="1C354D"/>
-          </a:solidFill>
-          <a:ln>
-            <a:noFill/>
-          </a:ln>
-        </p:spPr>
-        <p:style>
-          <a:lnRef idx="1">
-            <a:schemeClr val="accent1"/>
-          </a:lnRef>
-          <a:fillRef idx="3">
-            <a:schemeClr val="accent1"/>
-          </a:fillRef>
-          <a:effectRef idx="2">
-            <a:schemeClr val="accent1"/>
-          </a:effectRef>
-          <a:fontRef idx="minor">
-            <a:schemeClr val="lt1"/>
-          </a:fontRef>
-        </p:style>
-        <p:txBody>
-          <a:bodyPr rtlCol="0" anchor="ctr"/>
-          <a:lstStyle/>
-          <a:p>
-            <a:pPr algn="ctr"/>
-          </a:p>
-        </p:txBody>
-      </p:sp>
-      <p:sp>
-        <p:nvSpPr>
-          <p:cNvPr id="11" name="TextBox 10"/>
-          <p:cNvSpPr txBox="1"/>
-          <p:nvPr/>
-        </p:nvSpPr>
-        <p:spPr>
-          <a:xfrm>
-            <a:off x="6464808" y="2212848"/>
-            <a:ext cx="2377440" cy="502920"/>
-          </a:xfrm>
-          <a:prstGeom prst="rect">
-            <a:avLst/>
-          </a:prstGeom>
-          <a:noFill/>
-        </p:spPr>
-        <p:txBody>
-          <a:bodyPr wrap="square" lIns="18288" rIns="18288" tIns="18288" bIns="18288">
-            <a:spAutoFit/>
-          </a:bodyPr>
-          <a:lstStyle/>
-          <a:p>
-            <a:pPr>
-              <a:spcAft>
-                <a:spcPts val="1400"/>
-              </a:spcAft>
-              <a:defRPr sz="2200" b="1">
-                <a:solidFill>
-                  <a:srgbClr val="55D5C6"/>
-                </a:solidFill>
-                <a:latin typeface="Arial"/>
-              </a:defRPr>
-            </a:pPr>
-            <a:r>
-              <a:t>Attendance</a:t>
-            </a:r>
-          </a:p>
-        </p:txBody>
-      </p:sp>
-      <p:sp>
-        <p:nvSpPr>
-          <p:cNvPr id="12" name="TextBox 11"/>
-          <p:cNvSpPr txBox="1"/>
-          <p:nvPr/>
-        </p:nvSpPr>
-        <p:spPr>
-          <a:xfrm>
-            <a:off x="6464808" y="2852928"/>
-            <a:ext cx="2377440" cy="2377440"/>
-          </a:xfrm>
-          <a:prstGeom prst="rect">
-            <a:avLst/>
-          </a:prstGeom>
-          <a:noFill/>
-        </p:spPr>
-        <p:txBody>
-          <a:bodyPr wrap="square" lIns="18288" rIns="18288" tIns="18288" bIns="18288">
-            <a:spAutoFit/>
-          </a:bodyPr>
-          <a:lstStyle/>
-          <a:p>
-            <a:pPr>
-              <a:spcAft>
-                <a:spcPts val="1400"/>
-              </a:spcAft>
-              <a:defRPr sz="2000" b="0">
-                <a:solidFill>
-                  <a:srgbClr val="F5F8FC"/>
-                </a:solidFill>
-                <a:latin typeface="Arial"/>
-              </a:defRPr>
-            </a:pPr>
-            <a:r>
-              <a:t>Staff confirm + version</a:t>
-            </a:r>
-          </a:p>
-          <a:p>
-            <a:pPr>
-              <a:spcAft>
-                <a:spcPts val="1400"/>
-              </a:spcAft>
-              <a:defRPr sz="2000" b="0">
-                <a:solidFill>
-                  <a:srgbClr val="F5F8FC"/>
-                </a:solidFill>
-                <a:latin typeface="Arial"/>
-              </a:defRPr>
-            </a:pPr>
-            <a:r>
-              <a:t>Idempotency + ChangeLog</a:t>
-            </a:r>
-          </a:p>
-          <a:p>
-            <a:pPr>
-              <a:spcAft>
-                <a:spcPts val="1400"/>
-              </a:spcAft>
-              <a:defRPr sz="2000" b="0">
-                <a:solidFill>
-                  <a:srgbClr val="F5F8FC"/>
-                </a:solidFill>
-                <a:latin typeface="Arial"/>
-              </a:defRPr>
-            </a:pPr>
-            <a:r>
-              <a:t>Manual fallback</a:t>
-            </a:r>
-          </a:p>
-        </p:txBody>
-      </p:sp>
-      <p:sp>
-        <p:nvSpPr>
-          <p:cNvPr id="13" name="Rounded Rectangle 12"/>
-          <p:cNvSpPr/>
-          <p:nvPr/>
-        </p:nvSpPr>
-        <p:spPr>
-          <a:xfrm>
-            <a:off x="9153144" y="2011680"/>
-            <a:ext cx="2697480" cy="3383280"/>
-          </a:xfrm>
-          <a:prstGeom prst="roundRect">
-            <a:avLst/>
-          </a:prstGeom>
-          <a:solidFill>
-            <a:srgbClr val="1C354D"/>
-          </a:solidFill>
-          <a:ln>
-            <a:noFill/>
-          </a:ln>
-        </p:spPr>
-        <p:style>
-          <a:lnRef idx="1">
-            <a:schemeClr val="accent1"/>
-          </a:lnRef>
-          <a:fillRef idx="3">
-            <a:schemeClr val="accent1"/>
-          </a:fillRef>
-          <a:effectRef idx="2">
-            <a:schemeClr val="accent1"/>
-          </a:effectRef>
-          <a:fontRef idx="minor">
-            <a:schemeClr val="lt1"/>
-          </a:fontRef>
-        </p:style>
-        <p:txBody>
-          <a:bodyPr rtlCol="0" anchor="ctr"/>
-          <a:lstStyle/>
-          <a:p>
-            <a:pPr algn="ctr"/>
-          </a:p>
-        </p:txBody>
-      </p:sp>
-      <p:sp>
-        <p:nvSpPr>
-          <p:cNvPr id="14" name="TextBox 13"/>
-          <p:cNvSpPr txBox="1"/>
-          <p:nvPr/>
-        </p:nvSpPr>
-        <p:spPr>
-          <a:xfrm>
-            <a:off x="9317736" y="2212848"/>
-            <a:ext cx="2377440" cy="502920"/>
-          </a:xfrm>
-          <a:prstGeom prst="rect">
-            <a:avLst/>
-          </a:prstGeom>
-          <a:noFill/>
-        </p:spPr>
-        <p:txBody>
-          <a:bodyPr wrap="square" lIns="18288" rIns="18288" tIns="18288" bIns="18288">
-            <a:spAutoFit/>
-          </a:bodyPr>
-          <a:lstStyle/>
-          <a:p>
-            <a:pPr>
-              <a:spcAft>
-                <a:spcPts val="1400"/>
-              </a:spcAft>
-              <a:defRPr sz="2200" b="1">
-                <a:solidFill>
-                  <a:srgbClr val="55D5C6"/>
-                </a:solidFill>
-                <a:latin typeface="Arial"/>
-              </a:defRPr>
-            </a:pPr>
-            <a:r>
-              <a:t>Report / DB</a:t>
-            </a:r>
-          </a:p>
-        </p:txBody>
-      </p:sp>
-      <p:sp>
-        <p:nvSpPr>
-          <p:cNvPr id="15" name="TextBox 14"/>
-          <p:cNvSpPr txBox="1"/>
-          <p:nvPr/>
-        </p:nvSpPr>
-        <p:spPr>
-          <a:xfrm>
-            <a:off x="9317736" y="2852928"/>
-            <a:ext cx="2377440" cy="2377440"/>
-          </a:xfrm>
-          <a:prstGeom prst="rect">
-            <a:avLst/>
-          </a:prstGeom>
-          <a:noFill/>
-        </p:spPr>
-        <p:txBody>
-          <a:bodyPr wrap="square" lIns="18288" rIns="18288" tIns="18288" bIns="18288">
-            <a:spAutoFit/>
-          </a:bodyPr>
-          <a:lstStyle/>
-          <a:p>
-            <a:pPr>
-              <a:spcAft>
-                <a:spcPts val="1400"/>
-              </a:spcAft>
-              <a:defRPr sz="2000" b="0">
-                <a:solidFill>
-                  <a:srgbClr val="F5F8FC"/>
-                </a:solidFill>
-                <a:latin typeface="Arial"/>
-              </a:defRPr>
-            </a:pPr>
-            <a:r>
-              <a:t>JSON, XLSX, CSV</a:t>
-            </a:r>
-          </a:p>
-          <a:p>
-            <a:pPr>
-              <a:spcAft>
-                <a:spcPts val="1400"/>
-              </a:spcAft>
-              <a:defRPr sz="2000" b="0">
-                <a:solidFill>
-                  <a:srgbClr val="F5F8FC"/>
-                </a:solidFill>
-                <a:latin typeface="Arial"/>
-              </a:defRPr>
-            </a:pPr>
-            <a:r>
-              <a:t>Crop112×112 + embedding private</a:t>
-            </a:r>
-          </a:p>
-          <a:p>
-            <a:pPr>
-              <a:spcAft>
-                <a:spcPts val="1400"/>
-              </a:spcAft>
-              <a:defRPr sz="2000" b="0">
-                <a:solidFill>
-                  <a:srgbClr val="F5F8FC"/>
-                </a:solidFill>
-                <a:latin typeface="Arial"/>
-              </a:defRPr>
-            </a:pPr>
-            <a:r>
-              <a:t>Không lưu frame/video</a:t>
-            </a:r>
-          </a:p>
-        </p:txBody>
-      </p:sp>
-      <p:sp>
-        <p:nvSpPr>
-          <p:cNvPr id="16" name="TextBox 15"/>
+              <a:t>• Thiếu model hoặc ảnh chưa rõ: Chưa kiểm tra; không phạt tự động.</a:t>
+            </a:r>
+          </a:p>
+        </p:txBody>
+      </p:sp>
+      <p:sp>
+        <p:nvSpPr>
+          <p:cNvPr id="10" name="TextBox 9"/>
           <p:cNvSpPr txBox="1"/>
           <p:nvPr/>
         </p:nvSpPr>
@@ -5578,14 +5240,14 @@
               </a:defRPr>
             </a:pPr>
             <a:r>
-              <a:t>OpenCV MVP v1.4 | UI local | Nhân sự xác nhận bắt buộc</a:t>
-            </a:r>
-          </a:p>
-        </p:txBody>
-      </p:sp>
-      <p:sp>
-        <p:nvSpPr>
-          <p:cNvPr id="17" name="TextBox 16"/>
+              <a:t>OpenCV MVP v1.5 | Tự điểm danh | Giáo viên xử lý ngoại lệ</a:t>
+            </a:r>
+          </a:p>
+        </p:txBody>
+      </p:sp>
+      <p:sp>
+        <p:nvSpPr>
+          <p:cNvPr id="11" name="TextBox 10"/>
           <p:cNvSpPr txBox="1"/>
           <p:nvPr/>
         </p:nvSpPr>
@@ -5682,7 +5344,7 @@
               </a:defRPr>
             </a:pPr>
             <a:r>
-              <a:t>Demo trực tiếp bằng UI local</a:t>
+              <a:t>CRUD lớp và học sinh</a:t>
             </a:r>
           </a:p>
         </p:txBody>
@@ -5721,7 +5383,7 @@
               </a:defRPr>
             </a:pPr>
             <a:r>
-              <a:t>Thực hiện trên DB thử riêng và ảnh được phép sử dụng</a:t>
+              <a:t>Sĩ số tự tính, sức chứa chỉnh được</a:t>
             </a:r>
           </a:p>
         </p:txBody>
@@ -5803,7 +5465,7 @@
               </a:defRPr>
             </a:pPr>
             <a:r>
-              <a:t>Chuẩn bị / phân tích</a:t>
+              <a:t>Lớp</a:t>
             </a:r>
           </a:p>
         </p:txBody>
@@ -5842,7 +5504,7 @@
               </a:defRPr>
             </a:pPr>
             <a:r>
-              <a:t>• 1. Đăng nhập staff; chọn lớp và tạo/mở buổi đúng quyền.</a:t>
+              <a:t>• Mã/tên/khối/GVCN/sức chứa; lưu trữ và khôi phục.</a:t>
             </a:r>
           </a:p>
           <a:p>
@@ -5858,23 +5520,7 @@
               </a:defRPr>
             </a:pPr>
             <a:r>
-              <a:t>• 2. Mục Học sinh: đăng ký 3–10 ảnh mẫu riêng.</a:t>
-            </a:r>
-          </a:p>
-          <a:p>
-            <a:pPr>
-              <a:spcAft>
-                <a:spcPts val="1400"/>
-              </a:spcAft>
-              <a:defRPr sz="2100" b="0">
-                <a:solidFill>
-                  <a:srgbClr val="F5F8FC"/>
-                </a:solidFill>
-                <a:latin typeface="Arial"/>
-              </a:defRPr>
-            </a:pPr>
-            <a:r>
-              <a:t>• 3. Camera/upload → phân tích: PENDING, chưa ghi có mặt.</a:t>
+              <a:t>• Không giảm sức chứa dưới sĩ số, không xóa lịch sử.</a:t>
             </a:r>
           </a:p>
         </p:txBody>
@@ -5956,7 +5602,7 @@
               </a:defRPr>
             </a:pPr>
             <a:r>
-              <a:t>Xác nhận / đối soát</a:t>
+              <a:t>Học sinh</a:t>
             </a:r>
           </a:p>
         </p:txBody>
@@ -5995,7 +5641,7 @@
               </a:defRPr>
             </a:pPr>
             <a:r>
-              <a:t>• 4. Nhìn người thật rồi xác nhận danh tính; kiểm tra áo.</a:t>
+              <a:t>• Thêm/sửa/lưu trữ/khôi phục; giám thị chuyển lớp/sửa mã.</a:t>
             </a:r>
           </a:p>
           <a:p>
@@ -6011,23 +5657,7 @@
               </a:defRPr>
             </a:pPr>
             <a:r>
-              <a:t>• 5. Thử reject/manual; kiểm tra kết quả và source VISION.</a:t>
-            </a:r>
-          </a:p>
-          <a:p>
-            <a:pPr>
-              <a:spcAft>
-                <a:spcPts val="1400"/>
-              </a:spcAft>
-              <a:defRPr sz="2100" b="0">
-                <a:solidFill>
-                  <a:srgbClr val="F5F8FC"/>
-                </a:solidFill>
-                <a:latin typeface="Arial"/>
-              </a:defRPr>
-            </a:pPr>
-            <a:r>
-              <a:t>• 6. Chốt buổi; mở báo cáo, tải XLSX/CSV cùng bộ lọc.</a:t>
+              <a:t>• Học sinh mới vào buổi sau hoặc bổ sung OPEN có kiểm soát.</a:t>
             </a:r>
           </a:p>
         </p:txBody>
@@ -6066,7 +5696,7 @@
               </a:defRPr>
             </a:pPr>
             <a:r>
-              <a:t>OpenCV MVP v1.4 | UI local | Nhân sự xác nhận bắt buộc</a:t>
+              <a:t>OpenCV MVP v1.5 | Tự điểm danh | Giáo viên xử lý ngoại lệ</a:t>
             </a:r>
           </a:p>
         </p:txBody>
@@ -6170,7 +5800,7 @@
               </a:defRPr>
             </a:pPr>
             <a:r>
-              <a:t>Tình huống lỗi và đường thủ công</a:t>
+              <a:t>Demo trực tiếp</a:t>
             </a:r>
           </a:p>
         </p:txBody>
@@ -6209,7 +5839,7 @@
               </a:defRPr>
             </a:pPr>
             <a:r>
-              <a:t>Không biến kết quả chưa chắc chắn thành có mặt hoặc vi phạm</a:t>
+              <a:t>UI → API có scope/CSRF → database</a:t>
             </a:r>
           </a:p>
         </p:txBody>
@@ -6291,7 +5921,7 @@
               </a:defRPr>
             </a:pPr>
             <a:r>
-              <a:t>Ảnh / đồng phục</a:t>
+              <a:t>Thực hiện</a:t>
             </a:r>
           </a:p>
         </p:txBody>
@@ -6330,7 +5960,7 @@
               </a:defRPr>
             </a:pPr>
             <a:r>
-              <a:t>• Mặt lạ, mờ, nhiều mặt hoặc ứng viên sát nhau: chụp lại/manual.</a:t>
+              <a:t>• Đăng nhập, chọn lớp/buổi OPEN, đăng ký mẫu mặt riêng.</a:t>
             </a:r>
           </a:p>
           <a:p>
@@ -6346,23 +5976,7 @@
               </a:defRPr>
             </a:pPr>
             <a:r>
-              <a:t>• Áo bị che, thiếu vùng thân, màu không trội: UNKNOWN.</a:t>
-            </a:r>
-          </a:p>
-          <a:p>
-            <a:pPr>
-              <a:spcAft>
-                <a:spcPts val="1400"/>
-              </a:spcAft>
-              <a:defRPr sz="2100" b="0">
-                <a:solidFill>
-                  <a:srgbClr val="F5F8FC"/>
-                </a:solidFill>
-                <a:latin typeface="Arial"/>
-              </a:defRPr>
-            </a:pPr>
-            <a:r>
-              <a:t>• HSV không nhận biết logo, chất liệu hay đồng phục đầy đủ.</a:t>
+              <a:t>• Quét cặp ảnh ngoài enrollment: tự hiện Có mặt, không confirm.</a:t>
             </a:r>
           </a:p>
         </p:txBody>
@@ -6444,7 +6058,7 @@
               </a:defRPr>
             </a:pPr>
             <a:r>
-              <a:t>Trạng thái / quyền</a:t>
+              <a:t>Đối soát</a:t>
             </a:r>
           </a:p>
         </p:txBody>
@@ -6483,7 +6097,7 @@
               </a:defRPr>
             </a:pPr>
             <a:r>
-              <a:t>• Scan hết hạn, mẫu/version đổi, buổi đóng: không confirm mới.</a:t>
+              <a:t>• Quét lại giữ giờ đến đầu; người lạ không ghi có mặt.</a:t>
             </a:r>
           </a:p>
           <a:p>
@@ -6499,23 +6113,7 @@
               </a:defRPr>
             </a:pPr>
             <a:r>
-              <a:t>• GVCN khác lớp và học sinh bị chặn các API vision.</a:t>
-            </a:r>
-          </a:p>
-          <a:p>
-            <a:pPr>
-              <a:spcAft>
-                <a:spcPts val="1400"/>
-              </a:spcAft>
-              <a:defRPr sz="2100" b="0">
-                <a:solidFill>
-                  <a:srgbClr val="F5F8FC"/>
-                </a:solidFill>
-                <a:latin typeface="Arial"/>
-              </a:defRPr>
-            </a:pPr>
-            <a:r>
-              <a:t>• Mất camera/mạng: kiểm tra retry và chuyển manual.</a:t>
+              <a:t>• Mở Đồng phục, báo cáo và xuất CSV/XLSX; UNKNOWN vẫn riêng.</a:t>
             </a:r>
           </a:p>
         </p:txBody>
@@ -6554,7 +6152,7 @@
               </a:defRPr>
             </a:pPr>
             <a:r>
-              <a:t>OpenCV MVP v1.4 | UI local | Nhân sự xác nhận bắt buộc</a:t>
+              <a:t>OpenCV MVP v1.5 | Tự điểm danh | Giáo viên xử lý ngoại lệ</a:t>
             </a:r>
           </a:p>
         </p:txBody>
@@ -6658,7 +6256,7 @@
               </a:defRPr>
             </a:pPr>
             <a:r>
-              <a:t>Kiểm chứng và bằng chứng</a:t>
+              <a:t>Kiểm chứng và bảo vệ dữ liệu</a:t>
             </a:r>
           </a:p>
         </p:txBody>
@@ -6697,7 +6295,7 @@
               </a:defRPr>
             </a:pPr>
             <a:r>
-              <a:t>Chỉ trình bày kết quả từ log kiểm chứng hiện tại</a:t>
+              <a:t>Bằng chứng kỹ thuật, không thay PM acceptance</a:t>
             </a:r>
           </a:p>
         </p:txBody>
@@ -6779,7 +6377,7 @@
               </a:defRPr>
             </a:pPr>
             <a:r>
-              <a:t>Backend / dữ liệu</a:t>
+              <a:t>Các kiểm tra</a:t>
             </a:r>
           </a:p>
         </p:txBody>
@@ -6818,7 +6416,7 @@
               </a:defRPr>
             </a:pPr>
             <a:r>
-              <a:t>• Test scope, ảnh, matching, expiry, version, retry và rollback.</a:t>
+              <a:t>• Role/CSRF/private ảnh, stale version, retry và rollback.</a:t>
             </a:r>
           </a:p>
           <a:p>
@@ -6834,23 +6432,7 @@
               </a:defRPr>
             </a:pPr>
             <a:r>
-              <a:t>• Migrate DB mới/nâng cấp; check, migration drift và pip check.</a:t>
-            </a:r>
-          </a:p>
-          <a:p>
-            <a:pPr>
-              <a:spcAft>
-                <a:spcPts val="1400"/>
-              </a:spcAft>
-              <a:defRPr sz="2100" b="0">
-                <a:solidFill>
-                  <a:srgbClr val="F5F8FC"/>
-                </a:solidFill>
-                <a:latin typeface="Arial"/>
-              </a:defRPr>
-            </a:pPr>
-            <a:r>
-              <a:t>• Mở lại XLSX/CSV, so chi tiết và tổng với API.</a:t>
+              <a:t>• Review độc lập; migrate DB cũ, ảnh mặt thật và browser.</a:t>
             </a:r>
           </a:p>
         </p:txBody>
@@ -6932,7 +6514,7 @@
               </a:defRPr>
             </a:pPr>
             <a:r>
-              <a:t>Thiết bị / review</a:t>
+              <a:t>Dữ liệu</a:t>
             </a:r>
           </a:p>
         </p:txBody>
@@ -6971,7 +6553,7 @@
               </a:defRPr>
             </a:pPr>
             <a:r>
-              <a:t>• Fixture synthetic hoặc mock detector không chứng minh camera thật.</a:t>
+              <a:t>• Crop mặt và áo private, không lưu video/frame phân tích.</a:t>
             </a:r>
           </a:p>
           <a:p>
@@ -6987,23 +6569,7 @@
               </a:defRPr>
             </a:pPr>
             <a:r>
-              <a:t>• Thử ánh sáng, góc mặt, người lạ, áo bị che trên thiết bị thật.</a:t>
-            </a:r>
-          </a:p>
-          <a:p>
-            <a:pPr>
-              <a:spcAft>
-                <a:spcPts val="1400"/>
-              </a:spcAft>
-              <a:defRPr sz="2100" b="0">
-                <a:solidFill>
-                  <a:srgbClr val="F5F8FC"/>
-                </a:solidFill>
-                <a:latin typeface="Arial"/>
-              </a:defRPr>
-            </a:pPr>
-            <a:r>
-              <a:t>• Implementation + validation + review trước khi tick Finish?.</a:t>
+              <a:t>• Quyết định giáo viên không bị auto ghi đè; audit rõ nguồn.</a:t>
             </a:r>
           </a:p>
         </p:txBody>
@@ -7042,7 +6608,7 @@
               </a:defRPr>
             </a:pPr>
             <a:r>
-              <a:t>OpenCV MVP v1.4 | UI local | Nhân sự xác nhận bắt buộc</a:t>
+              <a:t>OpenCV MVP v1.5 | Tự điểm danh | Giáo viên xử lý ngoại lệ</a:t>
             </a:r>
           </a:p>
         </p:txBody>
@@ -7146,7 +6712,7 @@
               </a:defRPr>
             </a:pPr>
             <a:r>
-              <a:t>Giới hạn và bước tiếp theo</a:t>
+              <a:t>Giới hạn và phần còn chờ</a:t>
             </a:r>
           </a:p>
         </p:txBody>
@@ -7185,7 +6751,7 @@
               </a:defRPr>
             </a:pPr>
             <a:r>
-              <a:t>API_Gate = NOT_APPROVED • UI local là ngoại lệ do người dùng yêu cầu</a:t>
+              <a:t>Bộ ảnh trường là đầu vào cần thiết</a:t>
             </a:r>
           </a:p>
         </p:txBody>
@@ -7267,7 +6833,7 @@
               </a:defRPr>
             </a:pPr>
             <a:r>
-              <a:t>Giới hạn demo</a:t>
+              <a:t>Chưa nghiệm thu</a:t>
             </a:r>
           </a:p>
         </p:txBody>
@@ -7306,7 +6872,7 @@
               </a:defRPr>
             </a:pPr>
             <a:r>
-              <a:t>• Chưa có số liệu độ chính xác camera thật; không bảo đảm liveness.</a:t>
+              <a:t>• Cần ảnh trường và đối chứng logo/mẫu, ánh sáng/che áo.</a:t>
             </a:r>
           </a:p>
           <a:p>
@@ -7322,23 +6888,7 @@
               </a:defRPr>
             </a:pPr>
             <a:r>
-              <a:t>• HSV là heuristic màu; SQLite và cache dùng cho demo nhỏ.</a:t>
-            </a:r>
-          </a:p>
-          <a:p>
-            <a:pPr>
-              <a:spcAft>
-                <a:spcPts val="1400"/>
-              </a:spcAft>
-              <a:defRPr sz="2100" b="0">
-                <a:solidFill>
-                  <a:srgbClr val="F5F8FC"/>
-                </a:solidFill>
-                <a:latin typeface="Arial"/>
-              </a:defRPr>
-            </a:pPr>
-            <a:r>
-              <a:t>• Quota 20 phân tích/phút/actor: phút cố định, cache từng process.</a:t>
+              <a:t>• Chưa đo camera vật lý, độ chính xác toàn trường hay liveness.</a:t>
             </a:r>
           </a:p>
         </p:txBody>
@@ -7420,7 +6970,7 @@
               </a:defRPr>
             </a:pPr>
             <a:r>
-              <a:t>Bàn giao</a:t>
+              <a:t>Demo Vercel</a:t>
             </a:r>
           </a:p>
         </p:txBody>
@@ -7459,7 +7009,7 @@
               </a:defRPr>
             </a:pPr>
             <a:r>
-              <a:t>• PM xem evidence mới và quyết định API gate riêng.</a:t>
+              <a:t>• SQLite tạm theo instance, không đảm bảo dữ liệu dùng chung.</a:t>
             </a:r>
           </a:p>
           <a:p>
@@ -7475,23 +7025,7 @@
               </a:defRPr>
             </a:pPr>
             <a:r>
-              <a:t>• UI local đã có; browser/thiết bị thật cần evidence riêng.</a:t>
-            </a:r>
-          </a:p>
-          <a:p>
-            <a:pPr>
-              <a:spcAft>
-                <a:spcPts val="1400"/>
-              </a:spcAft>
-              <a:defRPr sz="2100" b="0">
-                <a:solidFill>
-                  <a:srgbClr val="F5F8FC"/>
-                </a:solidFill>
-                <a:latin typeface="Arial"/>
-              </a:defRPr>
-            </a:pPr>
-            <a:r>
-              <a:t>• Không tự deploy, chia sẻ ngoài hoặc đánh dấu mọi task hoàn tất.</a:t>
+              <a:t>• API/build được chuẩn bị; người dùng tự deploy, PM gate riêng.</a:t>
             </a:r>
           </a:p>
         </p:txBody>
@@ -7530,7 +7064,7 @@
               </a:defRPr>
             </a:pPr>
             <a:r>
-              <a:t>OpenCV MVP v1.4 | UI local | Nhân sự xác nhận bắt buộc</a:t>
+              <a:t>OpenCV MVP v1.5 | Tự điểm danh | Giáo viên xử lý ngoại lệ</a:t>
             </a:r>
           </a:p>
         </p:txBody>

</xml_diff>